<commit_message>
Add economics slide to retrospective PPT (AI vs outsourced cost)
PPTs are generated by scripts/generate-retro-pptx.py (python-pptx), so they ARE
editable. Add a "경제성 — 1인+AI vs 외주" content slide in the org-adoption
section (FP ~700, outsourced 6-9mo/3.5-5.5억 vs AI-solo 4.5mo/~4,500만,
~8-11x cheaper, ~7-8x productivity) and update the older cost bullet to match.
Regenerated retrospective-presentation.pptx (26 -> 27 slides).

Co-Authored-By: Claude Opus 4.8 <noreply@anthropic.com>
Claude-Session: https://claude.ai/code/session_01P8cfMfUC4BJWKAVFSN3YGi
</commit_message>
<xml_diff>
--- a/docs/retrospective-presentation.pptx
+++ b/docs/retrospective-presentation.pptx
@@ -31,6 +31,7 @@
     <p:sldId id="279" r:id="rId30"/>
     <p:sldId id="280" r:id="rId31"/>
     <p:sldId id="281" r:id="rId32"/>
+    <p:sldId id="282" r:id="rId33"/>
   </p:sldIdLst>
   <p:sldSz cx="12191695" cy="6858000" type="screen4x3"/>
   <p:notesSz cx="6858000" cy="9144000"/>
@@ -11738,7 +11739,7 @@
               </a:defRPr>
             </a:pPr>
             <a:r>
-              <a:t>AI 구독 월 수십만 원 vs 외주 수천만~1억 원</a:t>
+              <a:t>1인+AI 4.5개월·~4,500만 원 vs 외주 6~9개월·3.5~5.5억 원</a:t>
             </a:r>
           </a:p>
           <a:p>
@@ -11760,7 +11761,7 @@
               </a:defRPr>
             </a:pPr>
             <a:r>
-              <a:t>웹 비전공자 1명이 2.5개월에 DCIM 구축</a:t>
+              <a:t>비용 ~8~11배 절감 (상세: 다음 슬라이드)</a:t>
             </a:r>
           </a:p>
         </p:txBody>
@@ -12110,6 +12111,516 @@
 </file>
 
 <file path=ppt/slides/slide26.xml><?xml version="1.0" encoding="utf-8"?>
+<p:sld xmlns:a="http://schemas.openxmlformats.org/drawingml/2006/main" xmlns:p="http://schemas.openxmlformats.org/presentationml/2006/main" xmlns:r="http://schemas.openxmlformats.org/officeDocument/2006/relationships">
+  <p:cSld>
+    <p:bg>
+      <p:bgPr>
+        <a:solidFill>
+          <a:srgbClr val="FFFFFF"/>
+        </a:solidFill>
+        <a:effectLst/>
+      </p:bgPr>
+    </p:bg>
+    <p:spTree>
+      <p:nvGrpSpPr>
+        <p:cNvPr id="1" name=""/>
+        <p:cNvGrpSpPr/>
+        <p:nvPr/>
+      </p:nvGrpSpPr>
+      <p:grpSpPr/>
+      <p:sp>
+        <p:nvSpPr>
+          <p:cNvPr id="2" name="Rectangle 1"/>
+          <p:cNvSpPr/>
+          <p:nvPr/>
+        </p:nvSpPr>
+        <p:spPr>
+          <a:xfrm>
+            <a:off x="0" y="0"/>
+            <a:ext cx="12191695" cy="45720"/>
+          </a:xfrm>
+          <a:prstGeom prst="rect">
+            <a:avLst/>
+          </a:prstGeom>
+          <a:solidFill>
+            <a:srgbClr val="14B8A6"/>
+          </a:solidFill>
+          <a:ln>
+            <a:noFill/>
+          </a:ln>
+          <a:effectLst/>
+        </p:spPr>
+        <p:style>
+          <a:lnRef idx="1">
+            <a:schemeClr val="accent1"/>
+          </a:lnRef>
+          <a:fillRef idx="3">
+            <a:schemeClr val="accent1"/>
+          </a:fillRef>
+          <a:effectRef idx="2">
+            <a:schemeClr val="accent1"/>
+          </a:effectRef>
+          <a:fontRef idx="minor">
+            <a:schemeClr val="lt1"/>
+          </a:fontRef>
+        </p:style>
+        <p:txBody>
+          <a:bodyPr rtlCol="0" anchor="ctr"/>
+          <a:lstStyle/>
+          <a:p>
+            <a:pPr algn="ctr"/>
+          </a:p>
+        </p:txBody>
+      </p:sp>
+      <p:sp>
+        <p:nvSpPr>
+          <p:cNvPr id="3" name="TextBox 2"/>
+          <p:cNvSpPr txBox="1"/>
+          <p:nvPr/>
+        </p:nvSpPr>
+        <p:spPr>
+          <a:xfrm>
+            <a:off x="548640" y="274320"/>
+            <a:ext cx="10972800" cy="640080"/>
+          </a:xfrm>
+          <a:prstGeom prst="rect">
+            <a:avLst/>
+          </a:prstGeom>
+          <a:noFill/>
+        </p:spPr>
+        <p:txBody>
+          <a:bodyPr wrap="square">
+            <a:spAutoFit/>
+          </a:bodyPr>
+          <a:lstStyle/>
+          <a:p>
+            <a:pPr algn="l">
+              <a:defRPr sz="2600" b="1">
+                <a:solidFill>
+                  <a:srgbClr val="1F1F1F"/>
+                </a:solidFill>
+                <a:latin typeface="맑은 고딕"/>
+              </a:defRPr>
+            </a:pPr>
+            <a:r>
+              <a:t>경제성 — 1인+AI vs 외주 개발</a:t>
+            </a:r>
+          </a:p>
+        </p:txBody>
+      </p:sp>
+      <p:sp>
+        <p:nvSpPr>
+          <p:cNvPr id="4" name="Rectangle 3"/>
+          <p:cNvSpPr/>
+          <p:nvPr/>
+        </p:nvSpPr>
+        <p:spPr>
+          <a:xfrm>
+            <a:off x="548640" y="914400"/>
+            <a:ext cx="1828800" cy="32004"/>
+          </a:xfrm>
+          <a:prstGeom prst="rect">
+            <a:avLst/>
+          </a:prstGeom>
+          <a:solidFill>
+            <a:srgbClr val="14B8A6"/>
+          </a:solidFill>
+          <a:ln>
+            <a:noFill/>
+          </a:ln>
+          <a:effectLst/>
+        </p:spPr>
+        <p:style>
+          <a:lnRef idx="1">
+            <a:schemeClr val="accent1"/>
+          </a:lnRef>
+          <a:fillRef idx="3">
+            <a:schemeClr val="accent1"/>
+          </a:fillRef>
+          <a:effectRef idx="2">
+            <a:schemeClr val="accent1"/>
+          </a:effectRef>
+          <a:fontRef idx="minor">
+            <a:schemeClr val="lt1"/>
+          </a:fontRef>
+        </p:style>
+        <p:txBody>
+          <a:bodyPr rtlCol="0" anchor="ctr"/>
+          <a:lstStyle/>
+          <a:p>
+            <a:pPr algn="ctr"/>
+          </a:p>
+        </p:txBody>
+      </p:sp>
+      <p:sp>
+        <p:nvSpPr>
+          <p:cNvPr id="5" name="Rounded Rectangle 4"/>
+          <p:cNvSpPr/>
+          <p:nvPr/>
+        </p:nvSpPr>
+        <p:spPr>
+          <a:xfrm>
+            <a:off x="457200" y="1188720"/>
+            <a:ext cx="11247120" cy="5212080"/>
+          </a:xfrm>
+          <a:prstGeom prst="roundRect">
+            <a:avLst/>
+          </a:prstGeom>
+          <a:solidFill>
+            <a:srgbClr val="F8F9FB"/>
+          </a:solidFill>
+          <a:ln w="12700">
+            <a:solidFill>
+              <a:srgbClr val="E0E0E8"/>
+            </a:solidFill>
+          </a:ln>
+          <a:effectLst/>
+        </p:spPr>
+        <p:style>
+          <a:lnRef idx="1">
+            <a:schemeClr val="accent1"/>
+          </a:lnRef>
+          <a:fillRef idx="3">
+            <a:schemeClr val="accent1"/>
+          </a:fillRef>
+          <a:effectRef idx="2">
+            <a:schemeClr val="accent1"/>
+          </a:effectRef>
+          <a:fontRef idx="minor">
+            <a:schemeClr val="lt1"/>
+          </a:fontRef>
+        </p:style>
+        <p:txBody>
+          <a:bodyPr rtlCol="0" anchor="ctr"/>
+          <a:lstStyle/>
+          <a:p>
+            <a:pPr algn="ctr"/>
+          </a:p>
+        </p:txBody>
+      </p:sp>
+      <p:sp>
+        <p:nvSpPr>
+          <p:cNvPr id="6" name="TextBox 5"/>
+          <p:cNvSpPr txBox="1"/>
+          <p:nvPr/>
+        </p:nvSpPr>
+        <p:spPr>
+          <a:xfrm>
+            <a:off x="822960" y="1371600"/>
+            <a:ext cx="10515600" cy="4846320"/>
+          </a:xfrm>
+          <a:prstGeom prst="rect">
+            <a:avLst/>
+          </a:prstGeom>
+          <a:noFill/>
+        </p:spPr>
+        <p:txBody>
+          <a:bodyPr wrap="square">
+            <a:spAutoFit/>
+          </a:bodyPr>
+          <a:lstStyle/>
+          <a:p>
+            <a:pPr>
+              <a:lnSpc>
+                <a:spcPct val="140000"/>
+              </a:lnSpc>
+              <a:spcBef>
+                <a:spcPts val="600"/>
+              </a:spcBef>
+              <a:spcAft>
+                <a:spcPts val="200"/>
+              </a:spcAft>
+              <a:defRPr sz="1600" b="0">
+                <a:solidFill>
+                  <a:srgbClr val="1F1F1F"/>
+                </a:solidFill>
+                <a:latin typeface="맑은 고딕"/>
+              </a:defRPr>
+            </a:pPr>
+            <a:r>
+              <a:t>규모: 기능점수 ~700 FP · 44,211 LOC · API 74 · 화면 39 · DB 29모델</a:t>
+            </a:r>
+          </a:p>
+          <a:p>
+            <a:pPr>
+              <a:lnSpc>
+                <a:spcPct val="140000"/>
+              </a:lnSpc>
+              <a:spcBef>
+                <a:spcPts val="600"/>
+              </a:spcBef>
+              <a:spcAft>
+                <a:spcPts val="200"/>
+              </a:spcAft>
+              <a:defRPr sz="1600" b="0">
+                <a:solidFill>
+                  <a:srgbClr val="1F1F1F"/>
+                </a:solidFill>
+                <a:latin typeface="맑은 고딕"/>
+              </a:defRPr>
+            </a:pPr>
+          </a:p>
+          <a:p>
+            <a:pPr>
+              <a:lnSpc>
+                <a:spcPct val="140000"/>
+              </a:lnSpc>
+              <a:spcBef>
+                <a:spcPts val="600"/>
+              </a:spcBef>
+              <a:spcAft>
+                <a:spcPts val="200"/>
+              </a:spcAft>
+              <a:defRPr sz="1600" b="0">
+                <a:solidFill>
+                  <a:srgbClr val="1F1F1F"/>
+                </a:solidFill>
+                <a:latin typeface="맑은 고딕"/>
+              </a:defRPr>
+            </a:pPr>
+            <a:r>
+              <a:t>외주 예상 (팀 3~4명: PL·백엔드·프론트·QA)</a:t>
+            </a:r>
+          </a:p>
+          <a:p>
+            <a:pPr lvl="1">
+              <a:lnSpc>
+                <a:spcPct val="140000"/>
+              </a:lnSpc>
+              <a:spcBef>
+                <a:spcPts val="200"/>
+              </a:spcBef>
+              <a:spcAft>
+                <a:spcPts val="200"/>
+              </a:spcAft>
+              <a:defRPr sz="1500">
+                <a:solidFill>
+                  <a:srgbClr val="8C8C9A"/>
+                </a:solidFill>
+                <a:latin typeface="맑은 고딕"/>
+              </a:defRPr>
+            </a:pPr>
+            <a:r>
+              <a:t>기간 6~9개월 · 투입 25~35 맨먼스</a:t>
+            </a:r>
+          </a:p>
+          <a:p>
+            <a:pPr lvl="1">
+              <a:lnSpc>
+                <a:spcPct val="140000"/>
+              </a:lnSpc>
+              <a:spcBef>
+                <a:spcPts val="200"/>
+              </a:spcBef>
+              <a:spcAft>
+                <a:spcPts val="200"/>
+              </a:spcAft>
+              <a:defRPr sz="1500">
+                <a:solidFill>
+                  <a:srgbClr val="8C8C9A"/>
+                </a:solidFill>
+                <a:latin typeface="맑은 고딕"/>
+              </a:defRPr>
+            </a:pPr>
+            <a:r>
+              <a:t>비용 3.5~5.5억 원 (SI 대가 기준)</a:t>
+            </a:r>
+          </a:p>
+          <a:p>
+            <a:pPr>
+              <a:lnSpc>
+                <a:spcPct val="140000"/>
+              </a:lnSpc>
+              <a:spcBef>
+                <a:spcPts val="600"/>
+              </a:spcBef>
+              <a:spcAft>
+                <a:spcPts val="200"/>
+              </a:spcAft>
+              <a:defRPr sz="1600" b="0">
+                <a:solidFill>
+                  <a:srgbClr val="1F1F1F"/>
+                </a:solidFill>
+                <a:latin typeface="맑은 고딕"/>
+              </a:defRPr>
+            </a:pPr>
+          </a:p>
+          <a:p>
+            <a:pPr>
+              <a:lnSpc>
+                <a:spcPct val="140000"/>
+              </a:lnSpc>
+              <a:spcBef>
+                <a:spcPts val="600"/>
+              </a:spcBef>
+              <a:spcAft>
+                <a:spcPts val="200"/>
+              </a:spcAft>
+              <a:defRPr sz="1600" b="0">
+                <a:solidFill>
+                  <a:srgbClr val="1F1F1F"/>
+                </a:solidFill>
+                <a:latin typeface="맑은 고딕"/>
+              </a:defRPr>
+            </a:pPr>
+            <a:r>
+              <a:t>1인 + AI (실제)</a:t>
+            </a:r>
+          </a:p>
+          <a:p>
+            <a:pPr lvl="1">
+              <a:lnSpc>
+                <a:spcPct val="140000"/>
+              </a:lnSpc>
+              <a:spcBef>
+                <a:spcPts val="200"/>
+              </a:spcBef>
+              <a:spcAft>
+                <a:spcPts val="200"/>
+              </a:spcAft>
+              <a:defRPr sz="1500">
+                <a:solidFill>
+                  <a:srgbClr val="8C8C9A"/>
+                </a:solidFill>
+                <a:latin typeface="맑은 고딕"/>
+              </a:defRPr>
+            </a:pPr>
+            <a:r>
+              <a:t>기간 4.5개월 · 투입 4.5 맨먼스</a:t>
+            </a:r>
+          </a:p>
+          <a:p>
+            <a:pPr lvl="1">
+              <a:lnSpc>
+                <a:spcPct val="140000"/>
+              </a:lnSpc>
+              <a:spcBef>
+                <a:spcPts val="200"/>
+              </a:spcBef>
+              <a:spcAft>
+                <a:spcPts val="200"/>
+              </a:spcAft>
+              <a:defRPr sz="1500">
+                <a:solidFill>
+                  <a:srgbClr val="8C8C9A"/>
+                </a:solidFill>
+                <a:latin typeface="맑은 고딕"/>
+              </a:defRPr>
+            </a:pPr>
+            <a:r>
+              <a:t>비용 ~4,500만 원 (인건비 ~4천만 + AI 구독 ~100만)</a:t>
+            </a:r>
+          </a:p>
+          <a:p>
+            <a:pPr>
+              <a:lnSpc>
+                <a:spcPct val="140000"/>
+              </a:lnSpc>
+              <a:spcBef>
+                <a:spcPts val="600"/>
+              </a:spcBef>
+              <a:spcAft>
+                <a:spcPts val="200"/>
+              </a:spcAft>
+              <a:defRPr sz="1600" b="0">
+                <a:solidFill>
+                  <a:srgbClr val="1F1F1F"/>
+                </a:solidFill>
+                <a:latin typeface="맑은 고딕"/>
+              </a:defRPr>
+            </a:pPr>
+          </a:p>
+          <a:p>
+            <a:pPr>
+              <a:lnSpc>
+                <a:spcPct val="140000"/>
+              </a:lnSpc>
+              <a:spcBef>
+                <a:spcPts val="600"/>
+              </a:spcBef>
+              <a:spcAft>
+                <a:spcPts val="200"/>
+              </a:spcAft>
+              <a:defRPr sz="1600" b="0">
+                <a:solidFill>
+                  <a:srgbClr val="1F1F1F"/>
+                </a:solidFill>
+                <a:latin typeface="맑은 고딕"/>
+              </a:defRPr>
+            </a:pPr>
+            <a:r>
+              <a:t>효과: 비용 ~8~11배 절감 · 인당 생산성 ~155 FP/MM (외주 ~7~8배)</a:t>
+            </a:r>
+          </a:p>
+          <a:p>
+            <a:pPr>
+              <a:lnSpc>
+                <a:spcPct val="140000"/>
+              </a:lnSpc>
+              <a:spcBef>
+                <a:spcPts val="600"/>
+              </a:spcBef>
+              <a:spcAft>
+                <a:spcPts val="200"/>
+              </a:spcAft>
+              <a:defRPr sz="1600" b="0">
+                <a:solidFill>
+                  <a:srgbClr val="1F1F1F"/>
+                </a:solidFill>
+                <a:latin typeface="맑은 고딕"/>
+              </a:defRPr>
+            </a:pPr>
+            <a:r>
+              <a:t>1인 기준(AI 없이)이면 ~2.5~3년 → AI로 4.5개월 (약 6~8배 단축)</a:t>
+            </a:r>
+          </a:p>
+        </p:txBody>
+      </p:sp>
+      <p:sp>
+        <p:nvSpPr>
+          <p:cNvPr id="7" name="TextBox 6"/>
+          <p:cNvSpPr txBox="1"/>
+          <p:nvPr/>
+        </p:nvSpPr>
+        <p:spPr>
+          <a:xfrm>
+            <a:off x="10972800" y="6492240"/>
+            <a:ext cx="914400" cy="274320"/>
+          </a:xfrm>
+          <a:prstGeom prst="rect">
+            <a:avLst/>
+          </a:prstGeom>
+          <a:noFill/>
+        </p:spPr>
+        <p:txBody>
+          <a:bodyPr wrap="square">
+            <a:spAutoFit/>
+          </a:bodyPr>
+          <a:lstStyle/>
+          <a:p>
+            <a:pPr algn="r">
+              <a:defRPr sz="1000" b="0">
+                <a:solidFill>
+                  <a:srgbClr val="8C8C9A"/>
+                </a:solidFill>
+                <a:latin typeface="맑은 고딕"/>
+              </a:defRPr>
+            </a:pPr>
+            <a:r>
+              <a:t>26</a:t>
+            </a:r>
+          </a:p>
+        </p:txBody>
+      </p:sp>
+    </p:spTree>
+  </p:cSld>
+  <p:clrMapOvr>
+    <a:masterClrMapping/>
+  </p:clrMapOvr>
+</p:sld>
+</file>
+
+<file path=ppt/slides/slide27.xml><?xml version="1.0" encoding="utf-8"?>
 <p:sld xmlns:a="http://schemas.openxmlformats.org/drawingml/2006/main" xmlns:p="http://schemas.openxmlformats.org/presentationml/2006/main" xmlns:r="http://schemas.openxmlformats.org/officeDocument/2006/relationships">
   <p:cSld>
     <p:bg>

</xml_diff>

<commit_message>
docs: sync cost-comparison and retro PPT to current ground-truth numbers
어제 반영한 비용·생산성(FP/맨먼스) 내용의 잔여 미현행화 2곳 정리:

- cost-comparison-20260630.md: 커밋 571 → 576 (타 산출물과 통일)
- generate-retro-pptx.py: 옛 수치 일괄 정정 — 커밋 514→576,
  LOC 43,974→44,211(파일 215→218), API 73→74, 기능 134→135,
  번역 키 509→511, 확인 스크립트 72/29 → 116/31
- retrospective-presentation.pptx 재생성(27슬라이드) 및 수치 검증
  (576/44,211/74/135/4,500만/155 FP/MM 포함, stale 없음 확인)

Co-Authored-By: Claude Opus 4.8 <noreply@anthropic.com>
Claude-Session: https://claude.ai/code/session_01P8cfMfUC4BJWKAVFSN3YGi
</commit_message>
<xml_diff>
--- a/docs/retrospective-presentation.pptx
+++ b/docs/retrospective-presentation.pptx
@@ -3402,7 +3402,7 @@
               </a:defRPr>
             </a:pPr>
             <a:r>
-              <a:t>514 커밋  |  43,974줄  |  134개 기능  |  AI 99%+ 작성</a:t>
+              <a:t>576 커밋  |  44,211줄  |  135개 기능  |  AI 99%+ 작성</a:t>
             </a:r>
           </a:p>
           <a:p>
@@ -4031,7 +4031,7 @@
               </a:defRPr>
             </a:pPr>
             <a:r>
-              <a:t>커밋 분포 (514건)</a:t>
+              <a:t>커밋 분포 (576건)</a:t>
             </a:r>
           </a:p>
         </p:txBody>
@@ -10531,7 +10531,7 @@
               </a:defRPr>
             </a:pPr>
             <a:r>
-              <a:t>72개 확인 스크립트 + 29개 결과 기록</a:t>
+              <a:t>116개 확인 스크립트 + 31개 결과 기록</a:t>
             </a:r>
           </a:p>
           <a:p>
@@ -10900,7 +10900,7 @@
               </a:defRPr>
             </a:pPr>
             <a:r>
-              <a:t>514커밋 중 refactor 3건뿐 &gt; 기술 부채 축적</a:t>
+              <a:t>576커밋 중 refactor 3건뿐 &gt; 기술 부채 축적</a:t>
             </a:r>
           </a:p>
           <a:p>
@@ -10944,7 +10944,7 @@
               </a:defRPr>
             </a:pPr>
             <a:r>
-              <a:t>8개 테스트 파일로 43,974줄은 부족</a:t>
+              <a:t>8개 테스트 파일로 44,211줄은 부족</a:t>
             </a:r>
           </a:p>
           <a:p>
@@ -13658,7 +13658,7 @@
                         </a:defRPr>
                       </a:pPr>
                       <a:r>
-                        <a:t>514개 (AI 99%+ 작성)</a:t>
+                        <a:t>576개 (AI 99%+ 작성)</a:t>
                       </a:r>
                     </a:p>
                   </a:txBody>
@@ -13708,7 +13708,7 @@
                         </a:defRPr>
                       </a:pPr>
                       <a:r>
-                        <a:t>43,974줄 / 215개 파일</a:t>
+                        <a:t>44,211줄 / 218개 파일</a:t>
                       </a:r>
                     </a:p>
                   </a:txBody>
@@ -13758,7 +13758,7 @@
                         </a:defRPr>
                       </a:pPr>
                       <a:r>
-                        <a:t>73개</a:t>
+                        <a:t>74개</a:t>
                       </a:r>
                     </a:p>
                   </a:txBody>
@@ -13908,7 +13908,7 @@
                         </a:defRPr>
                       </a:pPr>
                       <a:r>
-                        <a:t>134개 (features.md 기준)</a:t>
+                        <a:t>135개 (features.md 기준)</a:t>
                       </a:r>
                     </a:p>
                   </a:txBody>
@@ -13958,7 +13958,7 @@
                         </a:defRPr>
                       </a:pPr>
                       <a:r>
-                        <a:t>72개 작성, 29개 결과 기록</a:t>
+                        <a:t>116개 작성, 31개 결과 기록</a:t>
                       </a:r>
                     </a:p>
                   </a:txBody>
@@ -14008,7 +14008,7 @@
                         </a:defRPr>
                       </a:pPr>
                       <a:r>
-                        <a:t>509개 키 (한/영)</a:t>
+                        <a:t>511개 키 (한/영)</a:t>
                       </a:r>
                     </a:p>
                   </a:txBody>
@@ -14899,7 +14899,7 @@
               </a:defRPr>
             </a:pPr>
             <a:r>
-              <a:t>통합 39페이지 + 73개 API</a:t>
+              <a:t>통합 39페이지 + 74개 API</a:t>
             </a:r>
           </a:p>
           <a:p>

</xml_diff>